<commit_message>
feat(figures): add PNG and SVG output formats with embedded images
- Updated R scripts to save figures in PDF, PNG, and SVG formats
- Human bulk RNA-seq: bubble plots in all formats
- Rat snRNA-seq: volcano plots and DA plots in all formats
- Added combined figure layouts for presentations
- Updated PowerPoint with embedded PNG images (1.8MB with figures)
- Added regenerate_figures.sbatch for easy figure regeneration

Co-Authored-By: Claude Opus 4.5 <noreply@anthropic.com>
</commit_message>
<xml_diff>
--- a/docs/biostatistical_corrections_summary.pptx
+++ b/docs/biostatistical_corrections_summary.pptx
@@ -3799,45 +3799,30 @@
           </a:p>
         </p:txBody>
       </p:sp>
-      <p:sp>
-        <p:nvSpPr>
-          <p:cNvPr id="3" name="TextBox 2"/>
-          <p:cNvSpPr txBox="1"/>
+      <p:pic>
+        <p:nvPicPr>
+          <p:cNvPr id="3" name="Picture 2" descr="correlation_bubbleplot_original.png"/>
+          <p:cNvPicPr>
+            <a:picLocks noChangeAspect="1"/>
+          </p:cNvPicPr>
           <p:nvPr/>
-        </p:nvSpPr>
+        </p:nvPicPr>
+        <p:blipFill>
+          <a:blip r:embed="rId2"/>
+          <a:stretch>
+            <a:fillRect/>
+          </a:stretch>
+        </p:blipFill>
         <p:spPr>
           <a:xfrm>
-            <a:off x="914400" y="2286000"/>
-            <a:ext cx="10058400" cy="1828800"/>
+            <a:off x="1371600" y="822960"/>
+            <a:ext cx="9144000" cy="5334000"/>
           </a:xfrm>
           <a:prstGeom prst="rect">
             <a:avLst/>
           </a:prstGeom>
-          <a:noFill/>
         </p:spPr>
-        <p:txBody>
-          <a:bodyPr wrap="none">
-            <a:spAutoFit/>
-          </a:bodyPr>
-          <a:lstStyle/>
-          <a:p>
-            <a:pPr algn="ctr">
-              <a:defRPr sz="2400" i="1"/>
-            </a:pPr>
-            <a:r>
-              <a:t>[See figure: correlation_bubbleplot_original.pdf]</a:t>
-            </a:r>
-          </a:p>
-          <a:p>
-            <a:pPr algn="ctr">
-              <a:defRPr sz="1400"/>
-            </a:pPr>
-            <a:r>
-              <a:t>Location: figures/by_analysis/human_bulk_rnaseq/correlation_bubbleplot_original.pdf</a:t>
-            </a:r>
-          </a:p>
-        </p:txBody>
-      </p:sp>
+      </p:pic>
       <p:sp>
         <p:nvSpPr>
           <p:cNvPr id="4" name="TextBox 3"/>
@@ -3918,45 +3903,30 @@
           </a:p>
         </p:txBody>
       </p:sp>
-      <p:sp>
-        <p:nvSpPr>
-          <p:cNvPr id="3" name="TextBox 2"/>
-          <p:cNvSpPr txBox="1"/>
+      <p:pic>
+        <p:nvPicPr>
+          <p:cNvPr id="3" name="Picture 2" descr="correlation_bubbleplot_fdr.png"/>
+          <p:cNvPicPr>
+            <a:picLocks noChangeAspect="1"/>
+          </p:cNvPicPr>
           <p:nvPr/>
-        </p:nvSpPr>
+        </p:nvPicPr>
+        <p:blipFill>
+          <a:blip r:embed="rId2"/>
+          <a:stretch>
+            <a:fillRect/>
+          </a:stretch>
+        </p:blipFill>
         <p:spPr>
           <a:xfrm>
-            <a:off x="914400" y="2286000"/>
-            <a:ext cx="10058400" cy="1828800"/>
+            <a:off x="1371600" y="822960"/>
+            <a:ext cx="9144000" cy="5334000"/>
           </a:xfrm>
           <a:prstGeom prst="rect">
             <a:avLst/>
           </a:prstGeom>
-          <a:noFill/>
         </p:spPr>
-        <p:txBody>
-          <a:bodyPr wrap="none">
-            <a:spAutoFit/>
-          </a:bodyPr>
-          <a:lstStyle/>
-          <a:p>
-            <a:pPr algn="ctr">
-              <a:defRPr sz="2400" i="1"/>
-            </a:pPr>
-            <a:r>
-              <a:t>[See figure: correlation_bubbleplot_fdr.pdf]</a:t>
-            </a:r>
-          </a:p>
-          <a:p>
-            <a:pPr algn="ctr">
-              <a:defRPr sz="1400"/>
-            </a:pPr>
-            <a:r>
-              <a:t>Location: figures/by_analysis/human_bulk_rnaseq/correlation_bubbleplot_fdr.pdf</a:t>
-            </a:r>
-          </a:p>
-        </p:txBody>
-      </p:sp>
+      </p:pic>
       <p:sp>
         <p:nvSpPr>
           <p:cNvPr id="4" name="TextBox 3"/>
@@ -4577,45 +4547,30 @@
           </a:p>
         </p:txBody>
       </p:sp>
-      <p:sp>
-        <p:nvSpPr>
-          <p:cNvPr id="3" name="TextBox 2"/>
-          <p:cNvSpPr txBox="1"/>
+      <p:pic>
+        <p:nvPicPr>
+          <p:cNvPr id="3" name="Picture 2" descr="DE_volcano_combined.png"/>
+          <p:cNvPicPr>
+            <a:picLocks noChangeAspect="1"/>
+          </p:cNvPicPr>
           <p:nvPr/>
-        </p:nvSpPr>
+        </p:nvPicPr>
+        <p:blipFill>
+          <a:blip r:embed="rId2"/>
+          <a:stretch>
+            <a:fillRect/>
+          </a:stretch>
+        </p:blipFill>
         <p:spPr>
           <a:xfrm>
-            <a:off x="914400" y="2286000"/>
-            <a:ext cx="10058400" cy="1828800"/>
+            <a:off x="1371600" y="822960"/>
+            <a:ext cx="9144000" cy="8001000"/>
           </a:xfrm>
           <a:prstGeom prst="rect">
             <a:avLst/>
           </a:prstGeom>
-          <a:noFill/>
         </p:spPr>
-        <p:txBody>
-          <a:bodyPr wrap="none">
-            <a:spAutoFit/>
-          </a:bodyPr>
-          <a:lstStyle/>
-          <a:p>
-            <a:pPr algn="ctr">
-              <a:defRPr sz="2400" i="1"/>
-            </a:pPr>
-            <a:r>
-              <a:t>[See figure: DE_volcano_plots.pdf]</a:t>
-            </a:r>
-          </a:p>
-          <a:p>
-            <a:pPr algn="ctr">
-              <a:defRPr sz="1400"/>
-            </a:pPr>
-            <a:r>
-              <a:t>Location: figures/by_analysis/rat_snrnaseq/DE_volcano_plots.pdf</a:t>
-            </a:r>
-          </a:p>
-        </p:txBody>
-      </p:sp>
+      </p:pic>
       <p:sp>
         <p:nvSpPr>
           <p:cNvPr id="4" name="TextBox 3"/>
@@ -4696,45 +4651,30 @@
           </a:p>
         </p:txBody>
       </p:sp>
-      <p:sp>
-        <p:nvSpPr>
-          <p:cNvPr id="3" name="TextBox 2"/>
-          <p:cNvSpPr txBox="1"/>
+      <p:pic>
+        <p:nvPicPr>
+          <p:cNvPr id="3" name="Picture 2" descr="DA_combined.png"/>
+          <p:cNvPicPr>
+            <a:picLocks noChangeAspect="1"/>
+          </p:cNvPicPr>
           <p:nvPr/>
-        </p:nvSpPr>
+        </p:nvPicPr>
+        <p:blipFill>
+          <a:blip r:embed="rId2"/>
+          <a:stretch>
+            <a:fillRect/>
+          </a:stretch>
+        </p:blipFill>
         <p:spPr>
           <a:xfrm>
-            <a:off x="914400" y="2286000"/>
-            <a:ext cx="10058400" cy="1828800"/>
+            <a:off x="1371600" y="822960"/>
+            <a:ext cx="9144000" cy="8001000"/>
           </a:xfrm>
           <a:prstGeom prst="rect">
             <a:avLst/>
           </a:prstGeom>
-          <a:noFill/>
         </p:spPr>
-        <p:txBody>
-          <a:bodyPr wrap="none">
-            <a:spAutoFit/>
-          </a:bodyPr>
-          <a:lstStyle/>
-          <a:p>
-            <a:pPr algn="ctr">
-              <a:defRPr sz="2400" i="1"/>
-            </a:pPr>
-            <a:r>
-              <a:t>[See figure: DA_proportion_plots.pdf]</a:t>
-            </a:r>
-          </a:p>
-          <a:p>
-            <a:pPr algn="ctr">
-              <a:defRPr sz="1400"/>
-            </a:pPr>
-            <a:r>
-              <a:t>Location: figures/by_analysis/rat_snrnaseq/DA_proportion_plots.pdf</a:t>
-            </a:r>
-          </a:p>
-        </p:txBody>
-      </p:sp>
+      </p:pic>
       <p:sp>
         <p:nvSpPr>
           <p:cNvPr id="4" name="TextBox 3"/>

</xml_diff>